<commit_message>
Updated PPT - Aarush Gupta
</commit_message>
<xml_diff>
--- a/Capston_PPT.pptx
+++ b/Capston_PPT.pptx
@@ -2252,7 +2252,7 @@
               <a:buNone/>
             </a:pPr>
             <a:r>
-              <a:rPr lang="en-US" sz="1150" b="1" dirty="0">
+              <a:rPr lang="en-US" sz="1050" b="1" dirty="0">
                 <a:solidFill>
                   <a:srgbClr val="FFFFFF"/>
                 </a:solidFill>
@@ -2260,22 +2260,132 @@
               </a:rPr>
               <a:t>Content surged post-2010</a:t>
             </a:r>
-            <a:endParaRPr lang="en-US" sz="1150" dirty="0"/>
           </a:p>
           <a:p>
             <a:pPr marL="0" indent="0">
               <a:buNone/>
             </a:pPr>
             <a:r>
-              <a:rPr lang="en-US" sz="1150" dirty="0">
+              <a:rPr lang="en-US" sz="850" dirty="0">
                 <a:solidFill>
                   <a:srgbClr val="B3B3B3"/>
                 </a:solidFill>
                 <a:latin typeface="Calibri" pitchFamily="34" charset="0"/>
               </a:rPr>
-              <a:t>with peak production around 2018–2020. The decline after 2020 reflects pandemic-era slowdowns and dataset cutoff effects.</a:t>
-            </a:r>
-            <a:endParaRPr lang="en-US" sz="1150" dirty="0"/>
+              <a:t>Peak production 2018-2020; post-2020 dip reflects pandemic &amp; cutoff effects.</a:t>
+            </a:r>
+          </a:p>
+          <a:p>
+            <a:pPr marL="0" indent="0">
+              <a:buNone/>
+            </a:pPr>
+            <a:r>
+              <a:rPr lang="en-US" sz="900" b="1" dirty="0">
+                <a:solidFill>
+                  <a:srgbClr val="E50914"/>
+                </a:solidFill>
+                <a:latin typeface="Calibri" pitchFamily="34" charset="0"/>
+              </a:rPr>
+              <a:t>🔍 Why This Happens</a:t>
+            </a:r>
+          </a:p>
+          <a:p>
+            <a:pPr marL="0" indent="0">
+              <a:buNone/>
+            </a:pPr>
+            <a:r>
+              <a:rPr lang="en-US" sz="850" dirty="0">
+                <a:solidFill>
+                  <a:srgbClr val="B3B3B3"/>
+                </a:solidFill>
+                <a:latin typeface="Calibri" pitchFamily="34" charset="0"/>
+              </a:rPr>
+              <a:t>▸ Global streaming boom (2015-2020) triggered massive original content investment</a:t>
+            </a:r>
+          </a:p>
+          <a:p>
+            <a:pPr marL="0" indent="0">
+              <a:buNone/>
+            </a:pPr>
+            <a:r>
+              <a:rPr lang="en-US" sz="850" dirty="0">
+                <a:solidFill>
+                  <a:srgbClr val="B3B3B3"/>
+                </a:solidFill>
+                <a:latin typeface="Calibri" pitchFamily="34" charset="0"/>
+              </a:rPr>
+              <a:t>▸ COVID-19 disrupted production pipelines causing measurable post-2020 decline</a:t>
+            </a:r>
+          </a:p>
+          <a:p>
+            <a:pPr marL="0" indent="0">
+              <a:buNone/>
+            </a:pPr>
+            <a:r>
+              <a:rPr lang="en-US" sz="900" b="1" dirty="0">
+                <a:solidFill>
+                  <a:srgbClr val="E50914"/>
+                </a:solidFill>
+                <a:latin typeface="Calibri" pitchFamily="34" charset="0"/>
+              </a:rPr>
+              <a:t>📌 Business Impact</a:t>
+            </a:r>
+          </a:p>
+          <a:p>
+            <a:pPr marL="0" indent="0">
+              <a:buNone/>
+            </a:pPr>
+            <a:r>
+              <a:rPr lang="en-US" sz="850" dirty="0">
+                <a:solidFill>
+                  <a:srgbClr val="B3B3B3"/>
+                </a:solidFill>
+                <a:latin typeface="Calibri" pitchFamily="34" charset="0"/>
+              </a:rPr>
+              <a:t>▸ 2015-2020 is the ‘golden window’ — benchmark content quality from this era</a:t>
+            </a:r>
+          </a:p>
+          <a:p>
+            <a:pPr marL="0" indent="0">
+              <a:buNone/>
+            </a:pPr>
+            <a:r>
+              <a:rPr lang="en-US" sz="850" dirty="0">
+                <a:solidFill>
+                  <a:srgbClr val="B3B3B3"/>
+                </a:solidFill>
+                <a:latin typeface="Calibri" pitchFamily="34" charset="0"/>
+              </a:rPr>
+              <a:t>▸ Production recovery post-2021 signals renewed platform confidence</a:t>
+            </a:r>
+          </a:p>
+          <a:p>
+            <a:pPr marL="0" indent="0">
+              <a:buNone/>
+            </a:pPr>
+            <a:r>
+              <a:rPr lang="en-US" sz="900" b="1" dirty="0">
+                <a:solidFill>
+                  <a:srgbClr val="E50914"/>
+                </a:solidFill>
+                <a:latin typeface="Calibri" pitchFamily="34" charset="0"/>
+              </a:rPr>
+              <a:t>📊 Highlight</a:t>
+            </a:r>
+          </a:p>
+          <a:p>
+            <a:pPr marL="0" indent="0">
+              <a:buNone/>
+            </a:pPr>
+            <a:r>
+              <a:rPr lang="en-US" sz="850" dirty="0">
+                <a:solidFill>
+                  <a:srgbClr val="B3B3B3"/>
+                </a:solidFill>
+                <a:latin typeface="Calibri" pitchFamily="34" charset="0"/>
+              </a:rPr>
+              <a:t>▸ Netflix-era titles (2015-2020) represent 45%+ of total catalog by volume</a:t>
+            </a:r>
           </a:p>
         </p:txBody>
       </p:sp>
@@ -2310,7 +2420,7 @@
                 </a:solidFill>
                 <a:latin typeface="Calibri" pitchFamily="34" charset="0"/>
               </a:rPr>
-              <a:t>Filtered: year ≥ 2000, votes &gt; 1000</a:t>
+              <a:t>Filtered: year ≥ 2000, votes &gt; 1,000; year extracted from range strings</a:t>
             </a:r>
             <a:endParaRPr lang="en-US" sz="1000" dirty="0"/>
           </a:p>
@@ -4646,7 +4756,7 @@
         </p:nvSpPr>
         <p:spPr>
           <a:xfrm>
-            <a:off x="365760" y="1417320"/>
+            <a:off x="365760" y="1316583"/>
             <a:ext cx="1828800" cy="1005840"/>
           </a:xfrm>
           <a:prstGeom prst="rect">
@@ -4685,7 +4795,7 @@
         </p:nvSpPr>
         <p:spPr>
           <a:xfrm>
-            <a:off x="365760" y="1463040"/>
+            <a:off x="365760" y="1362303"/>
             <a:ext cx="1828800" cy="548640"/>
           </a:xfrm>
           <a:prstGeom prst="rect">
@@ -4724,7 +4834,7 @@
         </p:nvSpPr>
         <p:spPr>
           <a:xfrm>
-            <a:off x="365760" y="2011680"/>
+            <a:off x="365760" y="1910943"/>
             <a:ext cx="1828800" cy="320040"/>
           </a:xfrm>
           <a:prstGeom prst="rect">
@@ -4763,7 +4873,7 @@
         </p:nvSpPr>
         <p:spPr>
           <a:xfrm>
-            <a:off x="2468880" y="1417320"/>
+            <a:off x="2468880" y="1316583"/>
             <a:ext cx="1828800" cy="1005840"/>
           </a:xfrm>
           <a:prstGeom prst="rect">
@@ -4802,7 +4912,7 @@
         </p:nvSpPr>
         <p:spPr>
           <a:xfrm>
-            <a:off x="2468880" y="1463040"/>
+            <a:off x="2468880" y="1362303"/>
             <a:ext cx="1828800" cy="548640"/>
           </a:xfrm>
           <a:prstGeom prst="rect">
@@ -4841,7 +4951,7 @@
         </p:nvSpPr>
         <p:spPr>
           <a:xfrm>
-            <a:off x="2468880" y="2011680"/>
+            <a:off x="2468880" y="1910943"/>
             <a:ext cx="1828800" cy="320040"/>
           </a:xfrm>
           <a:prstGeom prst="rect">
@@ -4880,7 +4990,7 @@
         </p:nvSpPr>
         <p:spPr>
           <a:xfrm>
-            <a:off x="4572000" y="1417320"/>
+            <a:off x="4572000" y="1316583"/>
             <a:ext cx="1828800" cy="1005840"/>
           </a:xfrm>
           <a:prstGeom prst="rect">
@@ -4919,7 +5029,7 @@
         </p:nvSpPr>
         <p:spPr>
           <a:xfrm>
-            <a:off x="4572000" y="1463040"/>
+            <a:off x="4572000" y="1362303"/>
             <a:ext cx="1828800" cy="548640"/>
           </a:xfrm>
           <a:prstGeom prst="rect">
@@ -4958,7 +5068,7 @@
         </p:nvSpPr>
         <p:spPr>
           <a:xfrm>
-            <a:off x="4572000" y="2011680"/>
+            <a:off x="4572000" y="1910943"/>
             <a:ext cx="1828800" cy="320040"/>
           </a:xfrm>
           <a:prstGeom prst="rect">
@@ -4997,7 +5107,7 @@
         </p:nvSpPr>
         <p:spPr>
           <a:xfrm>
-            <a:off x="6675120" y="1417320"/>
+            <a:off x="6675120" y="1316583"/>
             <a:ext cx="1828800" cy="1005840"/>
           </a:xfrm>
           <a:prstGeom prst="rect">
@@ -5036,7 +5146,7 @@
         </p:nvSpPr>
         <p:spPr>
           <a:xfrm>
-            <a:off x="6675120" y="1463040"/>
+            <a:off x="6675120" y="1362303"/>
             <a:ext cx="1828800" cy="548640"/>
           </a:xfrm>
           <a:prstGeom prst="rect">
@@ -5075,7 +5185,7 @@
         </p:nvSpPr>
         <p:spPr>
           <a:xfrm>
-            <a:off x="6675120" y="2011680"/>
+            <a:off x="6675120" y="1910943"/>
             <a:ext cx="1828800" cy="320040"/>
           </a:xfrm>
           <a:prstGeom prst="rect">
@@ -5115,13 +5225,13 @@
           <p:nvPr>
             <p:extLst>
               <p:ext uri="{D42A27DB-BD31-4B8C-83A1-F6EECF244321}">
-                <p14:modId xmlns:p14="http://schemas.microsoft.com/office/powerpoint/2010/main" val="1579011935"/>
+                <p14:modId xmlns:p14="http://schemas.microsoft.com/office/powerpoint/2010/main" val="366005137"/>
               </p:ext>
             </p:extLst>
           </p:nvPr>
         </p:nvGraphicFramePr>
         <p:xfrm>
-          <a:off x="365760" y="2606040"/>
+          <a:off x="412255" y="2381317"/>
           <a:ext cx="8046720" cy="2707640"/>
         </p:xfrm>
         <a:graphic>
@@ -9773,7 +9883,7 @@
               <a:buNone/>
             </a:pPr>
             <a:r>
-              <a:rPr lang="en-US" sz="1150" b="1" dirty="0">
+              <a:rPr lang="en-US" sz="1050" b="1" dirty="0">
                 <a:solidFill>
                   <a:srgbClr val="FFFFFF"/>
                 </a:solidFill>
@@ -9781,22 +9891,132 @@
               </a:rPr>
               <a:t>Comedy dominates Netflix</a:t>
             </a:r>
-            <a:endParaRPr lang="en-US" sz="1150" dirty="0"/>
           </a:p>
           <a:p>
             <a:pPr marL="0" indent="0">
               <a:buNone/>
             </a:pPr>
             <a:r>
-              <a:rPr lang="en-US" sz="1150" dirty="0">
+              <a:rPr lang="en-US" sz="850" dirty="0">
                 <a:solidFill>
                   <a:srgbClr val="B3B3B3"/>
                 </a:solidFill>
                 <a:latin typeface="Calibri" pitchFamily="34" charset="0"/>
               </a:rPr>
-              <a:t>with the most titles, followed by Drama and Action. Documentary has fewer titles but consistently higher ratings.</a:t>
-            </a:r>
-            <a:endParaRPr lang="en-US" sz="1150" dirty="0"/>
+              <a:t>Comedy (1,034) leads catalog by volume; Drama (906) follows.</a:t>
+            </a:r>
+          </a:p>
+          <a:p>
+            <a:pPr marL="0" indent="0">
+              <a:buNone/>
+            </a:pPr>
+            <a:r>
+              <a:rPr lang="en-US" sz="900" b="1" dirty="0">
+                <a:solidFill>
+                  <a:srgbClr val="E50914"/>
+                </a:solidFill>
+                <a:latin typeface="Calibri" pitchFamily="34" charset="0"/>
+              </a:rPr>
+              <a:t>🔍 Why This Happens</a:t>
+            </a:r>
+          </a:p>
+          <a:p>
+            <a:pPr marL="0" indent="0">
+              <a:buNone/>
+            </a:pPr>
+            <a:r>
+              <a:rPr lang="en-US" sz="850" dirty="0">
+                <a:solidFill>
+                  <a:srgbClr val="B3B3B3"/>
+                </a:solidFill>
+                <a:latin typeface="Calibri" pitchFamily="34" charset="0"/>
+              </a:rPr>
+              <a:t>▸ Comedy's broad demographic appeal drives high production volume</a:t>
+            </a:r>
+          </a:p>
+          <a:p>
+            <a:pPr marL="0" indent="0">
+              <a:buNone/>
+            </a:pPr>
+            <a:r>
+              <a:rPr lang="en-US" sz="850" dirty="0">
+                <a:solidFill>
+                  <a:srgbClr val="B3B3B3"/>
+                </a:solidFill>
+                <a:latin typeface="Calibri" pitchFamily="34" charset="0"/>
+              </a:rPr>
+              <a:t>▸ Niche genres like Documentary win on quality, not quantity</a:t>
+            </a:r>
+          </a:p>
+          <a:p>
+            <a:pPr marL="0" indent="0">
+              <a:buNone/>
+            </a:pPr>
+            <a:r>
+              <a:rPr lang="en-US" sz="900" b="1" dirty="0">
+                <a:solidFill>
+                  <a:srgbClr val="E50914"/>
+                </a:solidFill>
+                <a:latin typeface="Calibri" pitchFamily="34" charset="0"/>
+              </a:rPr>
+              <a:t>📌 Business Impact</a:t>
+            </a:r>
+          </a:p>
+          <a:p>
+            <a:pPr marL="0" indent="0">
+              <a:buNone/>
+            </a:pPr>
+            <a:r>
+              <a:rPr lang="en-US" sz="850" dirty="0">
+                <a:solidFill>
+                  <a:srgbClr val="B3B3B3"/>
+                </a:solidFill>
+                <a:latin typeface="Calibri" pitchFamily="34" charset="0"/>
+              </a:rPr>
+              <a:t>▸ Diversify into Biography &amp; Crime to lift avg. catalog rating</a:t>
+            </a:r>
+          </a:p>
+          <a:p>
+            <a:pPr marL="0" indent="0">
+              <a:buNone/>
+            </a:pPr>
+            <a:r>
+              <a:rPr lang="en-US" sz="850" dirty="0">
+                <a:solidFill>
+                  <a:srgbClr val="B3B3B3"/>
+                </a:solidFill>
+                <a:latin typeface="Calibri" pitchFamily="34" charset="0"/>
+              </a:rPr>
+              <a:t>▸ Comedy saturation reduces differentiation for new entrants</a:t>
+            </a:r>
+          </a:p>
+          <a:p>
+            <a:pPr marL="0" indent="0">
+              <a:buNone/>
+            </a:pPr>
+            <a:r>
+              <a:rPr lang="en-US" sz="900" b="1" dirty="0">
+                <a:solidFill>
+                  <a:srgbClr val="E50914"/>
+                </a:solidFill>
+                <a:latin typeface="Calibri" pitchFamily="34" charset="0"/>
+              </a:rPr>
+              <a:t>📊 Highlight</a:t>
+            </a:r>
+          </a:p>
+          <a:p>
+            <a:pPr marL="0" indent="0">
+              <a:buNone/>
+            </a:pPr>
+            <a:r>
+              <a:rPr lang="en-US" sz="850" dirty="0">
+                <a:solidFill>
+                  <a:srgbClr val="B3B3B3"/>
+                </a:solidFill>
+                <a:latin typeface="Calibri" pitchFamily="34" charset="0"/>
+              </a:rPr>
+              <a:t>▸ Documentary avg. rating ~0.8 pts higher than Comedy despite 60% fewer titles</a:t>
+            </a:r>
           </a:p>
         </p:txBody>
       </p:sp>
@@ -9831,7 +10051,7 @@
                 </a:solidFill>
                 <a:latin typeface="Calibri" pitchFamily="34" charset="0"/>
               </a:rPr>
-              <a:t>Based on actual dataset</a:t>
+              <a:t>Primary genre extracted from multi-genre field; top 10 by count shown</a:t>
             </a:r>
             <a:endParaRPr lang="en-US" sz="1000" dirty="0"/>
           </a:p>
@@ -10131,30 +10351,140 @@
               <a:buNone/>
             </a:pPr>
             <a:r>
-              <a:rPr lang="en-US" sz="1150" b="1" dirty="0">
+              <a:rPr lang="en-US" sz="1050" b="1" dirty="0">
                 <a:solidFill>
                   <a:srgbClr val="FFFFFF"/>
                 </a:solidFill>
                 <a:latin typeface="Calibri" pitchFamily="34" charset="0"/>
               </a:rPr>
-              <a:t>Most titles are 'Good'</a:t>
-            </a:r>
-            <a:endParaRPr lang="en-US" sz="1150" dirty="0"/>
+              <a:t>Most content is rated ‘Good’</a:t>
+            </a:r>
           </a:p>
           <a:p>
             <a:pPr marL="0" indent="0">
               <a:buNone/>
             </a:pPr>
             <a:r>
-              <a:rPr lang="en-US" sz="1150" dirty="0">
+              <a:rPr lang="en-US" sz="850" dirty="0">
                 <a:solidFill>
                   <a:srgbClr val="B3B3B3"/>
                 </a:solidFill>
                 <a:latin typeface="Calibri" pitchFamily="34" charset="0"/>
               </a:rPr>
-              <a:t>(rated 6–8), with a significant share rated 'Excellent' (8+). Very few titles fall in the 'Average' category, reflecting Netflix's quality curation.</a:t>
-            </a:r>
-            <a:endParaRPr lang="en-US" sz="1150" dirty="0"/>
+              <a:t>63.9% of titles rated Good (6-8); only 15.4% reach Excellent (8+).</a:t>
+            </a:r>
+          </a:p>
+          <a:p>
+            <a:pPr marL="0" indent="0">
+              <a:buNone/>
+            </a:pPr>
+            <a:r>
+              <a:rPr lang="en-US" sz="900" b="1" dirty="0">
+                <a:solidFill>
+                  <a:srgbClr val="E50914"/>
+                </a:solidFill>
+                <a:latin typeface="Calibri" pitchFamily="34" charset="0"/>
+              </a:rPr>
+              <a:t>🔍 Why This Happens</a:t>
+            </a:r>
+          </a:p>
+          <a:p>
+            <a:pPr marL="0" indent="0">
+              <a:buNone/>
+            </a:pPr>
+            <a:r>
+              <a:rPr lang="en-US" sz="850" dirty="0">
+                <a:solidFill>
+                  <a:srgbClr val="B3B3B3"/>
+                </a:solidFill>
+                <a:latin typeface="Calibri" pitchFamily="34" charset="0"/>
+              </a:rPr>
+              <a:t>▸ Netflix curates actively — very few sub-5 titles survive in catalog</a:t>
+            </a:r>
+          </a:p>
+          <a:p>
+            <a:pPr marL="0" indent="0">
+              <a:buNone/>
+            </a:pPr>
+            <a:r>
+              <a:rPr lang="en-US" sz="850" dirty="0">
+                <a:solidFill>
+                  <a:srgbClr val="B3B3B3"/>
+                </a:solidFill>
+                <a:latin typeface="Calibri" pitchFamily="34" charset="0"/>
+              </a:rPr>
+              <a:t>▸ Platform algorithmic promotion favors mid-tier ‘Good’ content</a:t>
+            </a:r>
+          </a:p>
+          <a:p>
+            <a:pPr marL="0" indent="0">
+              <a:buNone/>
+            </a:pPr>
+            <a:r>
+              <a:rPr lang="en-US" sz="900" b="1" dirty="0">
+                <a:solidFill>
+                  <a:srgbClr val="E50914"/>
+                </a:solidFill>
+                <a:latin typeface="Calibri" pitchFamily="34" charset="0"/>
+              </a:rPr>
+              <a:t>📌 Business Impact</a:t>
+            </a:r>
+          </a:p>
+          <a:p>
+            <a:pPr marL="0" indent="0">
+              <a:buNone/>
+            </a:pPr>
+            <a:r>
+              <a:rPr lang="en-US" sz="850" dirty="0">
+                <a:solidFill>
+                  <a:srgbClr val="B3B3B3"/>
+                </a:solidFill>
+                <a:latin typeface="Calibri" pitchFamily="34" charset="0"/>
+              </a:rPr>
+              <a:t>▸ Push Average-rated titles to Good via targeted editorial curation</a:t>
+            </a:r>
+          </a:p>
+          <a:p>
+            <a:pPr marL="0" indent="0">
+              <a:buNone/>
+            </a:pPr>
+            <a:r>
+              <a:rPr lang="en-US" sz="850" dirty="0">
+                <a:solidFill>
+                  <a:srgbClr val="B3B3B3"/>
+                </a:solidFill>
+                <a:latin typeface="Calibri" pitchFamily="34" charset="0"/>
+              </a:rPr>
+              <a:t>▸ Invest in Excellent-tier content to boost subscriber retention</a:t>
+            </a:r>
+          </a:p>
+          <a:p>
+            <a:pPr marL="0" indent="0">
+              <a:buNone/>
+            </a:pPr>
+            <a:r>
+              <a:rPr lang="en-US" sz="900" b="1" dirty="0">
+                <a:solidFill>
+                  <a:srgbClr val="E50914"/>
+                </a:solidFill>
+                <a:latin typeface="Calibri" pitchFamily="34" charset="0"/>
+              </a:rPr>
+              <a:t>📊 Highlight</a:t>
+            </a:r>
+          </a:p>
+          <a:p>
+            <a:pPr marL="0" indent="0">
+              <a:buNone/>
+            </a:pPr>
+            <a:r>
+              <a:rPr lang="en-US" sz="850" dirty="0">
+                <a:solidFill>
+                  <a:srgbClr val="B3B3B3"/>
+                </a:solidFill>
+                <a:latin typeface="Calibri" pitchFamily="34" charset="0"/>
+              </a:rPr>
+              <a:t>▸ Only 1 in 6 titles achieves Excellent status (8+ rating) on the platform</a:t>
+            </a:r>
           </a:p>
         </p:txBody>
       </p:sp>
@@ -10189,7 +10519,7 @@
                 </a:solidFill>
                 <a:latin typeface="Calibri" pitchFamily="34" charset="0"/>
               </a:rPr>
-              <a:t>Categories: Excellent ≥8, Good ≥6, else Average</a:t>
+              <a:t>Categories: Excellent ≥8, Good ≥6, Average &lt;6; rows with null ratings dropped</a:t>
             </a:r>
             <a:endParaRPr lang="en-US" sz="1000" dirty="0"/>
           </a:p>
@@ -10454,27 +10784,144 @@
           <a:bodyPr wrap="square" lIns="0" tIns="0" rIns="0" bIns="0" rtlCol="0" anchor="t"/>
           <a:lstStyle/>
           <a:p>
-            <a:r>
-              <a:rPr lang="en-US" sz="1150" b="1" dirty="0">
+            <a:pPr marL="0" indent="0">
+              <a:buNone/>
+            </a:pPr>
+            <a:r>
+              <a:rPr lang="en-US" sz="1050" b="1" dirty="0">
                 <a:solidFill>
                   <a:srgbClr val="FFFFFF"/>
                 </a:solidFill>
                 <a:latin typeface="Calibri" pitchFamily="34" charset="0"/>
               </a:rPr>
-              <a:t>Ratings peak around 6–7</a:t>
-            </a:r>
-          </a:p>
-          <a:p>
-            <a:r>
-              <a:rPr lang="en-US" sz="1150" dirty="0">
+              <a:t>Ratings peak at 6-7 (right-skewed)</a:t>
+            </a:r>
+          </a:p>
+          <a:p>
+            <a:pPr marL="0" indent="0">
+              <a:buNone/>
+            </a:pPr>
+            <a:r>
+              <a:rPr lang="en-US" sz="850" dirty="0">
                 <a:solidFill>
                   <a:srgbClr val="B3B3B3"/>
                 </a:solidFill>
                 <a:latin typeface="Calibri" pitchFamily="34" charset="0"/>
               </a:rPr>
-              <a:t>forming a near-normal distribution skewed slightly right. Very few titles fall below 5 or above 9, confirming Netflix filters extremes.</a:t>
-            </a:r>
-            <a:endParaRPr lang="en-US" sz="1150" dirty="0"/>
+              <a:t>Near-normal distribution; very few titles below 5 or above 9.</a:t>
+            </a:r>
+          </a:p>
+          <a:p>
+            <a:pPr marL="0" indent="0">
+              <a:buNone/>
+            </a:pPr>
+            <a:r>
+              <a:rPr lang="en-US" sz="900" b="1" dirty="0">
+                <a:solidFill>
+                  <a:srgbClr val="E50914"/>
+                </a:solidFill>
+                <a:latin typeface="Calibri" pitchFamily="34" charset="0"/>
+              </a:rPr>
+              <a:t>🔍 Why This Happens</a:t>
+            </a:r>
+          </a:p>
+          <a:p>
+            <a:pPr marL="0" indent="0">
+              <a:buNone/>
+            </a:pPr>
+            <a:r>
+              <a:rPr lang="en-US" sz="850" dirty="0">
+                <a:solidFill>
+                  <a:srgbClr val="B3B3B3"/>
+                </a:solidFill>
+                <a:latin typeface="Calibri" pitchFamily="34" charset="0"/>
+              </a:rPr>
+              <a:t>▸ Netflix filters low-quality content before it accumulates enough votes</a:t>
+            </a:r>
+          </a:p>
+          <a:p>
+            <a:pPr marL="0" indent="0">
+              <a:buNone/>
+            </a:pPr>
+            <a:r>
+              <a:rPr lang="en-US" sz="850" dirty="0">
+                <a:solidFill>
+                  <a:srgbClr val="B3B3B3"/>
+                </a:solidFill>
+                <a:latin typeface="Calibri" pitchFamily="34" charset="0"/>
+              </a:rPr>
+              <a:t>▸ Audience rating behavior clusters around ‘above average’ threshold</a:t>
+            </a:r>
+          </a:p>
+          <a:p>
+            <a:pPr marL="0" indent="0">
+              <a:buNone/>
+            </a:pPr>
+            <a:r>
+              <a:rPr lang="en-US" sz="900" b="1" dirty="0">
+                <a:solidFill>
+                  <a:srgbClr val="E50914"/>
+                </a:solidFill>
+                <a:latin typeface="Calibri" pitchFamily="34" charset="0"/>
+              </a:rPr>
+              <a:t>📌 Business Impact</a:t>
+            </a:r>
+          </a:p>
+          <a:p>
+            <a:pPr marL="0" indent="0">
+              <a:buNone/>
+            </a:pPr>
+            <a:r>
+              <a:rPr lang="en-US" sz="850" dirty="0">
+                <a:solidFill>
+                  <a:srgbClr val="B3B3B3"/>
+                </a:solidFill>
+                <a:latin typeface="Calibri" pitchFamily="34" charset="0"/>
+              </a:rPr>
+              <a:t>▸ Titles in the 6-7 range are breakout candidates with the right marketing push</a:t>
+            </a:r>
+          </a:p>
+          <a:p>
+            <a:pPr marL="0" indent="0">
+              <a:buNone/>
+            </a:pPr>
+            <a:r>
+              <a:rPr lang="en-US" sz="850" dirty="0">
+                <a:solidFill>
+                  <a:srgbClr val="B3B3B3"/>
+                </a:solidFill>
+                <a:latin typeface="Calibri" pitchFamily="34" charset="0"/>
+              </a:rPr>
+              <a:t>▸ Avoid investing in sub-6 content — low ceiling for audience engagement</a:t>
+            </a:r>
+          </a:p>
+          <a:p>
+            <a:pPr marL="0" indent="0">
+              <a:buNone/>
+            </a:pPr>
+            <a:r>
+              <a:rPr lang="en-US" sz="900" b="1" dirty="0">
+                <a:solidFill>
+                  <a:srgbClr val="E50914"/>
+                </a:solidFill>
+                <a:latin typeface="Calibri" pitchFamily="34" charset="0"/>
+              </a:rPr>
+              <a:t>📊 Highlight</a:t>
+            </a:r>
+          </a:p>
+          <a:p>
+            <a:pPr marL="0" indent="0">
+              <a:buNone/>
+            </a:pPr>
+            <a:r>
+              <a:rPr lang="en-US" sz="850" dirty="0">
+                <a:solidFill>
+                  <a:srgbClr val="B3B3B3"/>
+                </a:solidFill>
+                <a:latin typeface="Calibri" pitchFamily="34" charset="0"/>
+              </a:rPr>
+              <a:t>▸ Less than 5% of all titles score below 5 — Netflix's quality floor holds</a:t>
+            </a:r>
           </a:p>
         </p:txBody>
       </p:sp>
@@ -10509,7 +10956,7 @@
                 </a:solidFill>
                 <a:latin typeface="Calibri" pitchFamily="34" charset="0"/>
               </a:rPr>
-              <a:t>30-bin histogram, post-wrangling data</a:t>
+              <a:t>30-bin histogram; post-wrangling data with nulls removed and votes &gt; 0</a:t>
             </a:r>
             <a:endParaRPr lang="en-US" sz="1000" dirty="0"/>
           </a:p>
@@ -10809,30 +11256,140 @@
               <a:buNone/>
             </a:pPr>
             <a:r>
-              <a:rPr lang="en-US" sz="1150" b="1" dirty="0">
+              <a:rPr lang="en-US" sz="1050" b="1" dirty="0">
                 <a:solidFill>
                   <a:srgbClr val="FFFFFF"/>
                 </a:solidFill>
                 <a:latin typeface="Calibri" pitchFamily="34" charset="0"/>
               </a:rPr>
-              <a:t>Excellent titles attract far more votes</a:t>
-            </a:r>
-            <a:endParaRPr lang="en-US" sz="1150" dirty="0"/>
+              <a:t>Quality drives audience engagement</a:t>
+            </a:r>
           </a:p>
           <a:p>
             <a:pPr marL="0" indent="0">
               <a:buNone/>
             </a:pPr>
             <a:r>
-              <a:rPr lang="en-US" sz="1150" dirty="0">
+              <a:rPr lang="en-US" sz="850" dirty="0">
                 <a:solidFill>
                   <a:srgbClr val="B3B3B3"/>
                 </a:solidFill>
                 <a:latin typeface="Calibri" pitchFamily="34" charset="0"/>
               </a:rPr>
-              <a:t>— higher-rated content generates significantly more audience engagement. Most low-vote titles cluster in the 'Good' band (6–8).</a:t>
-            </a:r>
-            <a:endParaRPr lang="en-US" sz="1150" dirty="0"/>
+              <a:t>Excellent titles attract far more votes than Good or Average peers.</a:t>
+            </a:r>
+          </a:p>
+          <a:p>
+            <a:pPr marL="0" indent="0">
+              <a:buNone/>
+            </a:pPr>
+            <a:r>
+              <a:rPr lang="en-US" sz="900" b="1" dirty="0">
+                <a:solidFill>
+                  <a:srgbClr val="E50914"/>
+                </a:solidFill>
+                <a:latin typeface="Calibri" pitchFamily="34" charset="0"/>
+              </a:rPr>
+              <a:t>🔍 Why This Happens</a:t>
+            </a:r>
+          </a:p>
+          <a:p>
+            <a:pPr marL="0" indent="0">
+              <a:buNone/>
+            </a:pPr>
+            <a:r>
+              <a:rPr lang="en-US" sz="850" dirty="0">
+                <a:solidFill>
+                  <a:srgbClr val="B3B3B3"/>
+                </a:solidFill>
+                <a:latin typeface="Calibri" pitchFamily="34" charset="0"/>
+              </a:rPr>
+              <a:t>▸ Higher-rated content earns algorithmic boost, amplifying vote accumulation</a:t>
+            </a:r>
+          </a:p>
+          <a:p>
+            <a:pPr marL="0" indent="0">
+              <a:buNone/>
+            </a:pPr>
+            <a:r>
+              <a:rPr lang="en-US" sz="850" dirty="0">
+                <a:solidFill>
+                  <a:srgbClr val="B3B3B3"/>
+                </a:solidFill>
+                <a:latin typeface="Calibri" pitchFamily="34" charset="0"/>
+              </a:rPr>
+              <a:t>▸ Viewer word-of-mouth compounds for standout quality titles</a:t>
+            </a:r>
+          </a:p>
+          <a:p>
+            <a:pPr marL="0" indent="0">
+              <a:buNone/>
+            </a:pPr>
+            <a:r>
+              <a:rPr lang="en-US" sz="900" b="1" dirty="0">
+                <a:solidFill>
+                  <a:srgbClr val="E50914"/>
+                </a:solidFill>
+                <a:latin typeface="Calibri" pitchFamily="34" charset="0"/>
+              </a:rPr>
+              <a:t>📌 Business Impact</a:t>
+            </a:r>
+          </a:p>
+          <a:p>
+            <a:pPr marL="0" indent="0">
+              <a:buNone/>
+            </a:pPr>
+            <a:r>
+              <a:rPr lang="en-US" sz="850" dirty="0">
+                <a:solidFill>
+                  <a:srgbClr val="B3B3B3"/>
+                </a:solidFill>
+                <a:latin typeface="Calibri" pitchFamily="34" charset="0"/>
+              </a:rPr>
+              <a:t>▸ Prioritize quality over quantity — each Excellent title delivers outsized ROI</a:t>
+            </a:r>
+          </a:p>
+          <a:p>
+            <a:pPr marL="0" indent="0">
+              <a:buNone/>
+            </a:pPr>
+            <a:r>
+              <a:rPr lang="en-US" sz="850" dirty="0">
+                <a:solidFill>
+                  <a:srgbClr val="B3B3B3"/>
+                </a:solidFill>
+                <a:latin typeface="Calibri" pitchFamily="34" charset="0"/>
+              </a:rPr>
+              <a:t>▸ Engagement metrics can be used to predict future rating trajectory</a:t>
+            </a:r>
+          </a:p>
+          <a:p>
+            <a:pPr marL="0" indent="0">
+              <a:buNone/>
+            </a:pPr>
+            <a:r>
+              <a:rPr lang="en-US" sz="900" b="1" dirty="0">
+                <a:solidFill>
+                  <a:srgbClr val="E50914"/>
+                </a:solidFill>
+                <a:latin typeface="Calibri" pitchFamily="34" charset="0"/>
+              </a:rPr>
+              <a:t>📊 Highlight</a:t>
+            </a:r>
+          </a:p>
+          <a:p>
+            <a:pPr marL="0" indent="0">
+              <a:buNone/>
+            </a:pPr>
+            <a:r>
+              <a:rPr lang="en-US" sz="850" dirty="0">
+                <a:solidFill>
+                  <a:srgbClr val="B3B3B3"/>
+                </a:solidFill>
+                <a:latin typeface="Calibri" pitchFamily="34" charset="0"/>
+              </a:rPr>
+              <a:t>▸ Excellent-rated titles accumulate up to 1.8M+ votes vs avg. 50K for Good tier</a:t>
+            </a:r>
           </a:p>
         </p:txBody>
       </p:sp>
@@ -10867,7 +11424,7 @@
                 </a:solidFill>
                 <a:latin typeface="Calibri" pitchFamily="34" charset="0"/>
               </a:rPr>
-              <a:t>Colour-coded by rating_category</a:t>
+              <a:t>Scatter plot color-coded by rating_category; log scale on votes axis</a:t>
             </a:r>
             <a:endParaRPr lang="en-US" sz="1000" dirty="0"/>
           </a:p>

</xml_diff>